<commit_message>
fixed a bit more up to the wrangling - need to do the quarto
</commit_message>
<xml_diff>
--- a/docs/content/summary_stats/summary_stats_lecture.pptx
+++ b/docs/content/summary_stats/summary_stats_lecture.pptx
@@ -34,6 +34,8 @@
     <p:sldId id="282" r:id="rId28"/>
     <p:sldId id="283" r:id="rId29"/>
     <p:sldId id="284" r:id="rId30"/>
+    <p:sldId id="285" r:id="rId31"/>
+    <p:sldId id="286" r:id="rId32"/>
   </p:sldIdLst>
   <p:sldSz cx="9144000" cy="5143500" type="screen16x9"/>
   <p:notesSz cx="6858000" cy="9144000"/>
@@ -3368,7 +3370,7 @@
             </a:pPr>
             <a:r>
               <a:rPr/>
-              <a:t>2026-09-22</a:t>
+              <a:t>2026-09-23</a:t>
             </a:r>
           </a:p>
         </p:txBody>
@@ -9423,7 +9425,7 @@
         <p:spPr>
           <a:xfrm>
             <a:off x="0" y="0"/>
-            <a:ext cx="9144000" cy="582780"/>
+            <a:ext cx="9144000" cy="871538"/>
           </a:xfrm>
         </p:spPr>
         <p:txBody>
@@ -9446,6 +9448,1120 @@
           </a:p>
         </p:txBody>
       </p:sp>
+      <p:sp>
+        <p:nvSpPr>
+          <p:cNvPr id="4" name="Text Placeholder 3"/>
+          <p:cNvSpPr>
+            <a:spLocks noGrp="1"/>
+          </p:cNvSpPr>
+          <p:nvPr>
+            <p:ph idx="2" sz="half" type="body"/>
+          </p:nvPr>
+        </p:nvSpPr>
+        <p:spPr/>
+        <p:txBody>
+          <a:bodyPr/>
+          <a:lstStyle/>
+          <a:p>
+            <a:pPr lvl="0" indent="0">
+              <a:buNone/>
+            </a:pPr>
+            <a:r>
+              <a:rPr>
+                <a:solidFill>
+                  <a:srgbClr val="5E5E5E"/>
+                </a:solidFill>
+                <a:latin typeface="Courier"/>
+              </a:rPr>
+              <a:t># skim() grouped by shade — mass only -------------------</a:t>
+            </a:r>
+            <a:br/>
+            <a:r>
+              <a:rPr>
+                <a:solidFill>
+                  <a:srgbClr val="003B4F"/>
+                </a:solidFill>
+                <a:latin typeface="Courier"/>
+              </a:rPr>
+              <a:t>leaf_df </a:t>
+            </a:r>
+            <a:r>
+              <a:rPr>
+                <a:solidFill>
+                  <a:srgbClr val="5E5E5E"/>
+                </a:solidFill>
+                <a:latin typeface="Courier"/>
+              </a:rPr>
+              <a:t>%&gt;%</a:t>
+            </a:r>
+            <a:br/>
+            <a:r>
+              <a:rPr>
+                <a:solidFill>
+                  <a:srgbClr val="003B4F"/>
+                </a:solidFill>
+                <a:latin typeface="Courier"/>
+              </a:rPr>
+              <a:t>  </a:t>
+            </a:r>
+            <a:r>
+              <a:rPr>
+                <a:solidFill>
+                  <a:srgbClr val="4758AB"/>
+                </a:solidFill>
+                <a:latin typeface="Courier"/>
+              </a:rPr>
+              <a:t>select</a:t>
+            </a:r>
+            <a:r>
+              <a:rPr>
+                <a:solidFill>
+                  <a:srgbClr val="003B4F"/>
+                </a:solidFill>
+                <a:latin typeface="Courier"/>
+              </a:rPr>
+              <a:t>(shade, mass_g) </a:t>
+            </a:r>
+            <a:r>
+              <a:rPr>
+                <a:solidFill>
+                  <a:srgbClr val="5E5E5E"/>
+                </a:solidFill>
+                <a:latin typeface="Courier"/>
+              </a:rPr>
+              <a:t>%&gt;%</a:t>
+            </a:r>
+            <a:br/>
+            <a:r>
+              <a:rPr>
+                <a:solidFill>
+                  <a:srgbClr val="003B4F"/>
+                </a:solidFill>
+                <a:latin typeface="Courier"/>
+              </a:rPr>
+              <a:t>  </a:t>
+            </a:r>
+            <a:r>
+              <a:rPr>
+                <a:solidFill>
+                  <a:srgbClr val="4758AB"/>
+                </a:solidFill>
+                <a:latin typeface="Courier"/>
+              </a:rPr>
+              <a:t>group_by</a:t>
+            </a:r>
+            <a:r>
+              <a:rPr>
+                <a:solidFill>
+                  <a:srgbClr val="003B4F"/>
+                </a:solidFill>
+                <a:latin typeface="Courier"/>
+              </a:rPr>
+              <a:t>(shade) </a:t>
+            </a:r>
+            <a:r>
+              <a:rPr>
+                <a:solidFill>
+                  <a:srgbClr val="5E5E5E"/>
+                </a:solidFill>
+                <a:latin typeface="Courier"/>
+              </a:rPr>
+              <a:t>%&gt;%</a:t>
+            </a:r>
+            <a:br/>
+            <a:r>
+              <a:rPr>
+                <a:solidFill>
+                  <a:srgbClr val="003B4F"/>
+                </a:solidFill>
+                <a:latin typeface="Courier"/>
+              </a:rPr>
+              <a:t>  </a:t>
+            </a:r>
+            <a:r>
+              <a:rPr>
+                <a:solidFill>
+                  <a:srgbClr val="4758AB"/>
+                </a:solidFill>
+                <a:latin typeface="Courier"/>
+              </a:rPr>
+              <a:t>skim</a:t>
+            </a:r>
+            <a:r>
+              <a:rPr>
+                <a:solidFill>
+                  <a:srgbClr val="003B4F"/>
+                </a:solidFill>
+                <a:latin typeface="Courier"/>
+              </a:rPr>
+              <a:t>()</a:t>
+            </a:r>
+          </a:p>
+        </p:txBody>
+      </p:sp>
+      <p:graphicFrame>
+        <p:nvGraphicFramePr>
+          <p:cNvPr id="6" name="Content Placeholder 5"/>
+          <p:cNvGraphicFramePr>
+            <a:graphicFrameLocks noGrp="1"/>
+          </p:cNvGraphicFramePr>
+          <p:nvPr>
+            <p:ph idx="1"/>
+          </p:nvPr>
+        </p:nvGraphicFramePr>
+        <p:xfrm>
+          <a:off x="127000" y="2819400"/>
+          <a:ext cx="8750300" cy="1435100"/>
+        </p:xfrm>
+        <a:graphic>
+          <a:graphicData uri="http://schemas.openxmlformats.org/drawingml/2006/table">
+            <a:tbl>
+              <a:tblPr firstRow="0" bandRow="1">
+                <a:tableStyleId>{5C22544A-7EE6-4342-B048-85BDC9FD1C3A}</a:tableStyleId>
+              </a:tblPr>
+              <a:tblGrid>
+                <a:gridCol w="4368800"/>
+                <a:gridCol w="4368800"/>
+              </a:tblGrid>
+              <a:tr h="0">
+                <a:tc>
+                  <a:txBody>
+                    <a:bodyPr/>
+                    <a:lstStyle/>
+                    <a:p>
+                      <a:pPr lvl="0" indent="0" marL="0" algn="l">
+                        <a:buNone/>
+                      </a:pPr>
+                      <a:r>
+                        <a:rPr/>
+                        <a:t>Name</a:t>
+                      </a:r>
+                    </a:p>
+                  </a:txBody>
+                </a:tc>
+                <a:tc>
+                  <a:txBody>
+                    <a:bodyPr/>
+                    <a:lstStyle/>
+                    <a:p>
+                      <a:pPr lvl="0" indent="0" marL="0" algn="l">
+                        <a:buNone/>
+                      </a:pPr>
+                      <a:r>
+                        <a:rPr/>
+                        <a:t>Piped data</a:t>
+                      </a:r>
+                    </a:p>
+                  </a:txBody>
+                </a:tc>
+              </a:tr>
+              <a:tr h="0">
+                <a:tc>
+                  <a:txBody>
+                    <a:bodyPr/>
+                    <a:lstStyle/>
+                    <a:p>
+                      <a:pPr lvl="0" indent="0" marL="0" algn="l">
+                        <a:buNone/>
+                      </a:pPr>
+                      <a:r>
+                        <a:rPr/>
+                        <a:t>Number of rows</a:t>
+                      </a:r>
+                    </a:p>
+                  </a:txBody>
+                </a:tc>
+                <a:tc>
+                  <a:txBody>
+                    <a:bodyPr/>
+                    <a:lstStyle/>
+                    <a:p>
+                      <a:pPr lvl="0" indent="0" marL="0" algn="l">
+                        <a:buNone/>
+                      </a:pPr>
+                      <a:r>
+                        <a:rPr/>
+                        <a:t>53</a:t>
+                      </a:r>
+                    </a:p>
+                  </a:txBody>
+                </a:tc>
+              </a:tr>
+              <a:tr h="0">
+                <a:tc>
+                  <a:txBody>
+                    <a:bodyPr/>
+                    <a:lstStyle/>
+                    <a:p>
+                      <a:pPr lvl="0" indent="0" marL="0" algn="l">
+                        <a:buNone/>
+                      </a:pPr>
+                      <a:r>
+                        <a:rPr/>
+                        <a:t>Number of columns</a:t>
+                      </a:r>
+                    </a:p>
+                  </a:txBody>
+                </a:tc>
+                <a:tc>
+                  <a:txBody>
+                    <a:bodyPr/>
+                    <a:lstStyle/>
+                    <a:p>
+                      <a:pPr lvl="0" indent="0" marL="0" algn="l">
+                        <a:buNone/>
+                      </a:pPr>
+                      <a:r>
+                        <a:rPr/>
+                        <a:t>2</a:t>
+                      </a:r>
+                    </a:p>
+                  </a:txBody>
+                </a:tc>
+              </a:tr>
+              <a:tr h="0">
+                <a:tc>
+                  <a:txBody>
+                    <a:bodyPr/>
+                    <a:lstStyle/>
+                    <a:p>
+                      <a:pPr lvl="0" indent="0" marL="0" algn="l">
+                        <a:buNone/>
+                      </a:pPr>
+                      <a:r>
+                        <a:rPr/>
+                        <a:t>_______________________</a:t>
+                      </a:r>
+                    </a:p>
+                  </a:txBody>
+                </a:tc>
+                <a:tc>
+                  <a:txBody>
+                    <a:bodyPr/>
+                    <a:lstStyle/>
+                    <a:p>
+                      <a:endParaRPr/>
+                    </a:p>
+                  </a:txBody>
+                </a:tc>
+              </a:tr>
+              <a:tr h="0">
+                <a:tc>
+                  <a:txBody>
+                    <a:bodyPr/>
+                    <a:lstStyle/>
+                    <a:p>
+                      <a:pPr lvl="0" indent="0" marL="0" algn="l">
+                        <a:buNone/>
+                      </a:pPr>
+                      <a:r>
+                        <a:rPr/>
+                        <a:t>Column type frequency:</a:t>
+                      </a:r>
+                    </a:p>
+                  </a:txBody>
+                </a:tc>
+                <a:tc>
+                  <a:txBody>
+                    <a:bodyPr/>
+                    <a:lstStyle/>
+                    <a:p>
+                      <a:endParaRPr/>
+                    </a:p>
+                  </a:txBody>
+                </a:tc>
+              </a:tr>
+              <a:tr h="0">
+                <a:tc>
+                  <a:txBody>
+                    <a:bodyPr/>
+                    <a:lstStyle/>
+                    <a:p>
+                      <a:pPr lvl="0" indent="0" marL="0" algn="l">
+                        <a:buNone/>
+                      </a:pPr>
+                      <a:r>
+                        <a:rPr/>
+                        <a:t>numeric</a:t>
+                      </a:r>
+                    </a:p>
+                  </a:txBody>
+                </a:tc>
+                <a:tc>
+                  <a:txBody>
+                    <a:bodyPr/>
+                    <a:lstStyle/>
+                    <a:p>
+                      <a:pPr lvl="0" indent="0" marL="0" algn="l">
+                        <a:buNone/>
+                      </a:pPr>
+                      <a:r>
+                        <a:rPr/>
+                        <a:t>1</a:t>
+                      </a:r>
+                    </a:p>
+                  </a:txBody>
+                </a:tc>
+              </a:tr>
+              <a:tr h="0">
+                <a:tc>
+                  <a:txBody>
+                    <a:bodyPr/>
+                    <a:lstStyle/>
+                    <a:p>
+                      <a:pPr lvl="0" indent="0" marL="0" algn="l">
+                        <a:buNone/>
+                      </a:pPr>
+                      <a:r>
+                        <a:rPr/>
+                        <a:t>________________________</a:t>
+                      </a:r>
+                    </a:p>
+                  </a:txBody>
+                </a:tc>
+                <a:tc>
+                  <a:txBody>
+                    <a:bodyPr/>
+                    <a:lstStyle/>
+                    <a:p>
+                      <a:endParaRPr/>
+                    </a:p>
+                  </a:txBody>
+                </a:tc>
+              </a:tr>
+              <a:tr h="0">
+                <a:tc>
+                  <a:txBody>
+                    <a:bodyPr/>
+                    <a:lstStyle/>
+                    <a:p>
+                      <a:pPr lvl="0" indent="0" marL="0" algn="l">
+                        <a:buNone/>
+                      </a:pPr>
+                      <a:r>
+                        <a:rPr/>
+                        <a:t>Group variables</a:t>
+                      </a:r>
+                    </a:p>
+                  </a:txBody>
+                </a:tc>
+                <a:tc>
+                  <a:txBody>
+                    <a:bodyPr/>
+                    <a:lstStyle/>
+                    <a:p>
+                      <a:pPr lvl="0" indent="0" marL="0" algn="l">
+                        <a:buNone/>
+                      </a:pPr>
+                      <a:r>
+                        <a:rPr/>
+                        <a:t>shade</a:t>
+                      </a:r>
+                    </a:p>
+                  </a:txBody>
+                </a:tc>
+              </a:tr>
+            </a:tbl>
+          </a:graphicData>
+        </a:graphic>
+      </p:graphicFrame>
+      <p:sp>
+        <p:nvSpPr>
+          <p:cNvPr id="1" name="TextBox 3"/>
+          <p:cNvSpPr txBox="1"/>
+          <p:nvPr>
+            <p:ph idx="1"/>
+          </p:nvPr>
+        </p:nvSpPr>
+        <p:spPr>
+          <a:xfrm>
+            <a:off x="127000" y="4254500"/>
+            <a:ext cx="8750300" cy="508000"/>
+          </a:xfrm>
+          <a:prstGeom prst="rect">
+            <a:avLst/>
+          </a:prstGeom>
+          <a:noFill/>
+        </p:spPr>
+        <p:txBody>
+          <a:bodyPr/>
+          <a:lstStyle/>
+          <a:p>
+            <a:pPr lvl="0" indent="0" marL="0" algn="ctr">
+              <a:buNone/>
+            </a:pPr>
+            <a:r>
+              <a:rPr/>
+              <a:t>Data summary</a:t>
+            </a:r>
+          </a:p>
+        </p:txBody>
+      </p:sp>
+    </p:spTree>
+  </p:cSld>
+</p:sld>
+</file>
+
+<file path=ppt/slides/slide27.xml><?xml version="1.0" encoding="utf-8"?>
+<p:sld xmlns:a="http://schemas.openxmlformats.org/drawingml/2006/main" xmlns:r="http://schemas.openxmlformats.org/officeDocument/2006/relationships" xmlns:p="http://schemas.openxmlformats.org/presentationml/2006/main">
+  <p:cSld>
+    <p:spTree>
+      <p:nvGrpSpPr>
+        <p:cNvPr id="1" name=""/>
+        <p:cNvGrpSpPr/>
+        <p:nvPr/>
+      </p:nvGrpSpPr>
+      <p:grpSpPr>
+        <a:xfrm>
+          <a:off x="0" y="0"/>
+          <a:ext cx="0" cy="0"/>
+          <a:chOff x="0" y="0"/>
+          <a:chExt cx="0" cy="0"/>
+        </a:xfrm>
+      </p:grpSpPr>
+      <p:sp>
+        <p:nvSpPr>
+          <p:cNvPr id="4" name="Text Placeholder 3"/>
+          <p:cNvSpPr>
+            <a:spLocks noGrp="1"/>
+          </p:cNvSpPr>
+          <p:nvPr>
+            <p:ph idx="2" sz="half" type="body"/>
+          </p:nvPr>
+        </p:nvSpPr>
+        <p:spPr/>
+        <p:txBody>
+          <a:bodyPr/>
+          <a:lstStyle/>
+          <a:p>
+            <a:pPr lvl="0" indent="0" marL="0">
+              <a:buNone/>
+            </a:pPr>
+            <a:r>
+              <a:rPr b="1"/>
+              <a:t>Variable type: numeric</a:t>
+            </a:r>
+          </a:p>
+        </p:txBody>
+      </p:sp>
+      <p:graphicFrame>
+        <p:nvGraphicFramePr>
+          <p:cNvPr id="6" name="Content Placeholder 5"/>
+          <p:cNvGraphicFramePr>
+            <a:graphicFrameLocks noGrp="1"/>
+          </p:cNvGraphicFramePr>
+          <p:nvPr>
+            <p:ph idx="1"/>
+          </p:nvPr>
+        </p:nvGraphicFramePr>
+        <p:xfrm>
+          <a:off x="127000" y="2819400"/>
+          <a:ext cx="8750300" cy="1943100"/>
+        </p:xfrm>
+        <a:graphic>
+          <a:graphicData uri="http://schemas.openxmlformats.org/drawingml/2006/table">
+            <a:tbl>
+              <a:tblPr firstRow="1" bandRow="1">
+                <a:tableStyleId>{5C22544A-7EE6-4342-B048-85BDC9FD1C3A}</a:tableStyleId>
+              </a:tblPr>
+              <a:tblGrid>
+                <a:gridCol w="1435100"/>
+                <a:gridCol w="622300"/>
+                <a:gridCol w="1028700"/>
+                <a:gridCol w="1435100"/>
+                <a:gridCol w="520700"/>
+                <a:gridCol w="520700"/>
+                <a:gridCol w="520700"/>
+                <a:gridCol w="520700"/>
+                <a:gridCol w="520700"/>
+                <a:gridCol w="520700"/>
+                <a:gridCol w="520700"/>
+                <a:gridCol w="622300"/>
+              </a:tblGrid>
+              <a:tr h="0">
+                <a:tc>
+                  <a:txBody>
+                    <a:bodyPr/>
+                    <a:lstStyle/>
+                    <a:p>
+                      <a:pPr lvl="0" indent="0" marL="0" algn="l">
+                        <a:buNone/>
+                      </a:pPr>
+                      <a:r>
+                        <a:rPr/>
+                        <a:t>skim_variable</a:t>
+                      </a:r>
+                    </a:p>
+                  </a:txBody>
+                  <a:tcPr/>
+                </a:tc>
+                <a:tc>
+                  <a:txBody>
+                    <a:bodyPr/>
+                    <a:lstStyle/>
+                    <a:p>
+                      <a:pPr lvl="0" indent="0" marL="0" algn="l">
+                        <a:buNone/>
+                      </a:pPr>
+                      <a:r>
+                        <a:rPr/>
+                        <a:t>shade</a:t>
+                      </a:r>
+                    </a:p>
+                  </a:txBody>
+                  <a:tcPr/>
+                </a:tc>
+                <a:tc>
+                  <a:txBody>
+                    <a:bodyPr/>
+                    <a:lstStyle/>
+                    <a:p>
+                      <a:pPr lvl="0" indent="0" marL="0" algn="r">
+                        <a:buNone/>
+                      </a:pPr>
+                      <a:r>
+                        <a:rPr/>
+                        <a:t>n_missing</a:t>
+                      </a:r>
+                    </a:p>
+                  </a:txBody>
+                  <a:tcPr/>
+                </a:tc>
+                <a:tc>
+                  <a:txBody>
+                    <a:bodyPr/>
+                    <a:lstStyle/>
+                    <a:p>
+                      <a:pPr lvl="0" indent="0" marL="0" algn="r">
+                        <a:buNone/>
+                      </a:pPr>
+                      <a:r>
+                        <a:rPr/>
+                        <a:t>complete_rate</a:t>
+                      </a:r>
+                    </a:p>
+                  </a:txBody>
+                  <a:tcPr/>
+                </a:tc>
+                <a:tc>
+                  <a:txBody>
+                    <a:bodyPr/>
+                    <a:lstStyle/>
+                    <a:p>
+                      <a:pPr lvl="0" indent="0" marL="0" algn="r">
+                        <a:buNone/>
+                      </a:pPr>
+                      <a:r>
+                        <a:rPr/>
+                        <a:t>mean</a:t>
+                      </a:r>
+                    </a:p>
+                  </a:txBody>
+                  <a:tcPr/>
+                </a:tc>
+                <a:tc>
+                  <a:txBody>
+                    <a:bodyPr/>
+                    <a:lstStyle/>
+                    <a:p>
+                      <a:pPr lvl="0" indent="0" marL="0" algn="r">
+                        <a:buNone/>
+                      </a:pPr>
+                      <a:r>
+                        <a:rPr/>
+                        <a:t>sd</a:t>
+                      </a:r>
+                    </a:p>
+                  </a:txBody>
+                  <a:tcPr/>
+                </a:tc>
+                <a:tc>
+                  <a:txBody>
+                    <a:bodyPr/>
+                    <a:lstStyle/>
+                    <a:p>
+                      <a:pPr lvl="0" indent="0" marL="0" algn="r">
+                        <a:buNone/>
+                      </a:pPr>
+                      <a:r>
+                        <a:rPr/>
+                        <a:t>p0</a:t>
+                      </a:r>
+                    </a:p>
+                  </a:txBody>
+                  <a:tcPr/>
+                </a:tc>
+                <a:tc>
+                  <a:txBody>
+                    <a:bodyPr/>
+                    <a:lstStyle/>
+                    <a:p>
+                      <a:pPr lvl="0" indent="0" marL="0" algn="r">
+                        <a:buNone/>
+                      </a:pPr>
+                      <a:r>
+                        <a:rPr/>
+                        <a:t>p25</a:t>
+                      </a:r>
+                    </a:p>
+                  </a:txBody>
+                  <a:tcPr/>
+                </a:tc>
+                <a:tc>
+                  <a:txBody>
+                    <a:bodyPr/>
+                    <a:lstStyle/>
+                    <a:p>
+                      <a:pPr lvl="0" indent="0" marL="0" algn="r">
+                        <a:buNone/>
+                      </a:pPr>
+                      <a:r>
+                        <a:rPr/>
+                        <a:t>p50</a:t>
+                      </a:r>
+                    </a:p>
+                  </a:txBody>
+                  <a:tcPr/>
+                </a:tc>
+                <a:tc>
+                  <a:txBody>
+                    <a:bodyPr/>
+                    <a:lstStyle/>
+                    <a:p>
+                      <a:pPr lvl="0" indent="0" marL="0" algn="r">
+                        <a:buNone/>
+                      </a:pPr>
+                      <a:r>
+                        <a:rPr/>
+                        <a:t>p75</a:t>
+                      </a:r>
+                    </a:p>
+                  </a:txBody>
+                  <a:tcPr/>
+                </a:tc>
+                <a:tc>
+                  <a:txBody>
+                    <a:bodyPr/>
+                    <a:lstStyle/>
+                    <a:p>
+                      <a:pPr lvl="0" indent="0" marL="0" algn="r">
+                        <a:buNone/>
+                      </a:pPr>
+                      <a:r>
+                        <a:rPr/>
+                        <a:t>p100</a:t>
+                      </a:r>
+                    </a:p>
+                  </a:txBody>
+                  <a:tcPr/>
+                </a:tc>
+                <a:tc>
+                  <a:txBody>
+                    <a:bodyPr/>
+                    <a:lstStyle/>
+                    <a:p>
+                      <a:pPr lvl="0" indent="0" marL="0" algn="l">
+                        <a:buNone/>
+                      </a:pPr>
+                      <a:r>
+                        <a:rPr/>
+                        <a:t>hist</a:t>
+                      </a:r>
+                    </a:p>
+                  </a:txBody>
+                  <a:tcPr/>
+                </a:tc>
+              </a:tr>
+              <a:tr h="0">
+                <a:tc>
+                  <a:txBody>
+                    <a:bodyPr/>
+                    <a:lstStyle/>
+                    <a:p>
+                      <a:pPr lvl="0" indent="0" marL="0" algn="l">
+                        <a:buNone/>
+                      </a:pPr>
+                      <a:r>
+                        <a:rPr/>
+                        <a:t>mass_g</a:t>
+                      </a:r>
+                    </a:p>
+                  </a:txBody>
+                </a:tc>
+                <a:tc>
+                  <a:txBody>
+                    <a:bodyPr/>
+                    <a:lstStyle/>
+                    <a:p>
+                      <a:pPr lvl="0" indent="0" marL="0" algn="l">
+                        <a:buNone/>
+                      </a:pPr>
+                      <a:r>
+                        <a:rPr/>
+                        <a:t>shady</a:t>
+                      </a:r>
+                    </a:p>
+                  </a:txBody>
+                </a:tc>
+                <a:tc>
+                  <a:txBody>
+                    <a:bodyPr/>
+                    <a:lstStyle/>
+                    <a:p>
+                      <a:pPr lvl="0" indent="0" marL="0" algn="r">
+                        <a:buNone/>
+                      </a:pPr>
+                      <a:r>
+                        <a:rPr/>
+                        <a:t>0</a:t>
+                      </a:r>
+                    </a:p>
+                  </a:txBody>
+                </a:tc>
+                <a:tc>
+                  <a:txBody>
+                    <a:bodyPr/>
+                    <a:lstStyle/>
+                    <a:p>
+                      <a:pPr lvl="0" indent="0" marL="0" algn="r">
+                        <a:buNone/>
+                      </a:pPr>
+                      <a:r>
+                        <a:rPr/>
+                        <a:t>1</a:t>
+                      </a:r>
+                    </a:p>
+                  </a:txBody>
+                </a:tc>
+                <a:tc>
+                  <a:txBody>
+                    <a:bodyPr/>
+                    <a:lstStyle/>
+                    <a:p>
+                      <a:pPr lvl="0" indent="0" marL="0" algn="r">
+                        <a:buNone/>
+                      </a:pPr>
+                      <a:r>
+                        <a:rPr/>
+                        <a:t>0.52</a:t>
+                      </a:r>
+                    </a:p>
+                  </a:txBody>
+                </a:tc>
+                <a:tc>
+                  <a:txBody>
+                    <a:bodyPr/>
+                    <a:lstStyle/>
+                    <a:p>
+                      <a:pPr lvl="0" indent="0" marL="0" algn="r">
+                        <a:buNone/>
+                      </a:pPr>
+                      <a:r>
+                        <a:rPr/>
+                        <a:t>0.15</a:t>
+                      </a:r>
+                    </a:p>
+                  </a:txBody>
+                </a:tc>
+                <a:tc>
+                  <a:txBody>
+                    <a:bodyPr/>
+                    <a:lstStyle/>
+                    <a:p>
+                      <a:pPr lvl="0" indent="0" marL="0" algn="r">
+                        <a:buNone/>
+                      </a:pPr>
+                      <a:r>
+                        <a:rPr/>
+                        <a:t>0.34</a:t>
+                      </a:r>
+                    </a:p>
+                  </a:txBody>
+                </a:tc>
+                <a:tc>
+                  <a:txBody>
+                    <a:bodyPr/>
+                    <a:lstStyle/>
+                    <a:p>
+                      <a:pPr lvl="0" indent="0" marL="0" algn="r">
+                        <a:buNone/>
+                      </a:pPr>
+                      <a:r>
+                        <a:rPr/>
+                        <a:t>0.42</a:t>
+                      </a:r>
+                    </a:p>
+                  </a:txBody>
+                </a:tc>
+                <a:tc>
+                  <a:txBody>
+                    <a:bodyPr/>
+                    <a:lstStyle/>
+                    <a:p>
+                      <a:pPr lvl="0" indent="0" marL="0" algn="r">
+                        <a:buNone/>
+                      </a:pPr>
+                      <a:r>
+                        <a:rPr/>
+                        <a:t>0.52</a:t>
+                      </a:r>
+                    </a:p>
+                  </a:txBody>
+                </a:tc>
+                <a:tc>
+                  <a:txBody>
+                    <a:bodyPr/>
+                    <a:lstStyle/>
+                    <a:p>
+                      <a:pPr lvl="0" indent="0" marL="0" algn="r">
+                        <a:buNone/>
+                      </a:pPr>
+                      <a:r>
+                        <a:rPr/>
+                        <a:t>0.59</a:t>
+                      </a:r>
+                    </a:p>
+                  </a:txBody>
+                </a:tc>
+                <a:tc>
+                  <a:txBody>
+                    <a:bodyPr/>
+                    <a:lstStyle/>
+                    <a:p>
+                      <a:pPr lvl="0" indent="0" marL="0" algn="r">
+                        <a:buNone/>
+                      </a:pPr>
+                      <a:r>
+                        <a:rPr/>
+                        <a:t>0.92</a:t>
+                      </a:r>
+                    </a:p>
+                  </a:txBody>
+                </a:tc>
+                <a:tc>
+                  <a:txBody>
+                    <a:bodyPr/>
+                    <a:lstStyle/>
+                    <a:p>
+                      <a:pPr lvl="0" indent="0" marL="0" algn="l">
+                        <a:buNone/>
+                      </a:pPr>
+                      <a:r>
+                        <a:rPr/>
+                        <a:t>▇▅▃▁▁</a:t>
+                      </a:r>
+                    </a:p>
+                  </a:txBody>
+                </a:tc>
+              </a:tr>
+              <a:tr h="0">
+                <a:tc>
+                  <a:txBody>
+                    <a:bodyPr/>
+                    <a:lstStyle/>
+                    <a:p>
+                      <a:pPr lvl="0" indent="0" marL="0" algn="l">
+                        <a:buNone/>
+                      </a:pPr>
+                      <a:r>
+                        <a:rPr/>
+                        <a:t>mass_g</a:t>
+                      </a:r>
+                    </a:p>
+                  </a:txBody>
+                </a:tc>
+                <a:tc>
+                  <a:txBody>
+                    <a:bodyPr/>
+                    <a:lstStyle/>
+                    <a:p>
+                      <a:pPr lvl="0" indent="0" marL="0" algn="l">
+                        <a:buNone/>
+                      </a:pPr>
+                      <a:r>
+                        <a:rPr/>
+                        <a:t>sunny</a:t>
+                      </a:r>
+                    </a:p>
+                  </a:txBody>
+                </a:tc>
+                <a:tc>
+                  <a:txBody>
+                    <a:bodyPr/>
+                    <a:lstStyle/>
+                    <a:p>
+                      <a:pPr lvl="0" indent="0" marL="0" algn="r">
+                        <a:buNone/>
+                      </a:pPr>
+                      <a:r>
+                        <a:rPr/>
+                        <a:t>0</a:t>
+                      </a:r>
+                    </a:p>
+                  </a:txBody>
+                </a:tc>
+                <a:tc>
+                  <a:txBody>
+                    <a:bodyPr/>
+                    <a:lstStyle/>
+                    <a:p>
+                      <a:pPr lvl="0" indent="0" marL="0" algn="r">
+                        <a:buNone/>
+                      </a:pPr>
+                      <a:r>
+                        <a:rPr/>
+                        <a:t>1</a:t>
+                      </a:r>
+                    </a:p>
+                  </a:txBody>
+                </a:tc>
+                <a:tc>
+                  <a:txBody>
+                    <a:bodyPr/>
+                    <a:lstStyle/>
+                    <a:p>
+                      <a:pPr lvl="0" indent="0" marL="0" algn="r">
+                        <a:buNone/>
+                      </a:pPr>
+                      <a:r>
+                        <a:rPr/>
+                        <a:t>0.51</a:t>
+                      </a:r>
+                    </a:p>
+                  </a:txBody>
+                </a:tc>
+                <a:tc>
+                  <a:txBody>
+                    <a:bodyPr/>
+                    <a:lstStyle/>
+                    <a:p>
+                      <a:pPr lvl="0" indent="0" marL="0" algn="r">
+                        <a:buNone/>
+                      </a:pPr>
+                      <a:r>
+                        <a:rPr/>
+                        <a:t>0.21</a:t>
+                      </a:r>
+                    </a:p>
+                  </a:txBody>
+                </a:tc>
+                <a:tc>
+                  <a:txBody>
+                    <a:bodyPr/>
+                    <a:lstStyle/>
+                    <a:p>
+                      <a:pPr lvl="0" indent="0" marL="0" algn="r">
+                        <a:buNone/>
+                      </a:pPr>
+                      <a:r>
+                        <a:rPr/>
+                        <a:t>0.19</a:t>
+                      </a:r>
+                    </a:p>
+                  </a:txBody>
+                </a:tc>
+                <a:tc>
+                  <a:txBody>
+                    <a:bodyPr/>
+                    <a:lstStyle/>
+                    <a:p>
+                      <a:pPr lvl="0" indent="0" marL="0" algn="r">
+                        <a:buNone/>
+                      </a:pPr>
+                      <a:r>
+                        <a:rPr/>
+                        <a:t>0.35</a:t>
+                      </a:r>
+                    </a:p>
+                  </a:txBody>
+                </a:tc>
+                <a:tc>
+                  <a:txBody>
+                    <a:bodyPr/>
+                    <a:lstStyle/>
+                    <a:p>
+                      <a:pPr lvl="0" indent="0" marL="0" algn="r">
+                        <a:buNone/>
+                      </a:pPr>
+                      <a:r>
+                        <a:rPr/>
+                        <a:t>0.48</a:t>
+                      </a:r>
+                    </a:p>
+                  </a:txBody>
+                </a:tc>
+                <a:tc>
+                  <a:txBody>
+                    <a:bodyPr/>
+                    <a:lstStyle/>
+                    <a:p>
+                      <a:pPr lvl="0" indent="0" marL="0" algn="r">
+                        <a:buNone/>
+                      </a:pPr>
+                      <a:r>
+                        <a:rPr/>
+                        <a:t>0.65</a:t>
+                      </a:r>
+                    </a:p>
+                  </a:txBody>
+                </a:tc>
+                <a:tc>
+                  <a:txBody>
+                    <a:bodyPr/>
+                    <a:lstStyle/>
+                    <a:p>
+                      <a:pPr lvl="0" indent="0" marL="0" algn="r">
+                        <a:buNone/>
+                      </a:pPr>
+                      <a:r>
+                        <a:rPr/>
+                        <a:t>1.08</a:t>
+                      </a:r>
+                    </a:p>
+                  </a:txBody>
+                </a:tc>
+                <a:tc>
+                  <a:txBody>
+                    <a:bodyPr/>
+                    <a:lstStyle/>
+                    <a:p>
+                      <a:pPr lvl="0" indent="0" marL="0" algn="l">
+                        <a:buNone/>
+                      </a:pPr>
+                      <a:r>
+                        <a:rPr/>
+                        <a:t>▇▇▆▃▁</a:t>
+                      </a:r>
+                    </a:p>
+                  </a:txBody>
+                </a:tc>
+              </a:tr>
+            </a:tbl>
+          </a:graphicData>
+        </a:graphic>
+      </p:graphicFrame>
+    </p:spTree>
+  </p:cSld>
+</p:sld>
+</file>
+
+<file path=ppt/slides/slide28.xml><?xml version="1.0" encoding="utf-8"?>
+<p:sld xmlns:a="http://schemas.openxmlformats.org/drawingml/2006/main" xmlns:r="http://schemas.openxmlformats.org/officeDocument/2006/relationships" xmlns:p="http://schemas.openxmlformats.org/presentationml/2006/main">
+  <p:cSld>
+    <p:spTree>
+      <p:nvGrpSpPr>
+        <p:cNvPr id="1" name=""/>
+        <p:cNvGrpSpPr/>
+        <p:nvPr/>
+      </p:nvGrpSpPr>
+      <p:grpSpPr>
+        <a:xfrm>
+          <a:off x="0" y="0"/>
+          <a:ext cx="0" cy="0"/>
+          <a:chOff x="0" y="0"/>
+          <a:chExt cx="0" cy="0"/>
+        </a:xfrm>
+      </p:grpSpPr>
       <p:sp>
         <p:nvSpPr>
           <p:cNvPr id="3" name="Content Placeholder 2"/>
@@ -9461,150 +10577,6 @@
           <a:bodyPr/>
           <a:lstStyle/>
           <a:p>
-            <a:pPr lvl="0" indent="0">
-              <a:buNone/>
-            </a:pPr>
-            <a:r>
-              <a:rPr>
-                <a:solidFill>
-                  <a:srgbClr val="5E5E5E"/>
-                </a:solidFill>
-                <a:latin typeface="Courier"/>
-              </a:rPr>
-              <a:t># skim() grouped by shade — mass only -------------------</a:t>
-            </a:r>
-            <a:br/>
-            <a:r>
-              <a:rPr>
-                <a:solidFill>
-                  <a:srgbClr val="003B4F"/>
-                </a:solidFill>
-                <a:latin typeface="Courier"/>
-              </a:rPr>
-              <a:t>leaf_df </a:t>
-            </a:r>
-            <a:r>
-              <a:rPr>
-                <a:solidFill>
-                  <a:srgbClr val="5E5E5E"/>
-                </a:solidFill>
-                <a:latin typeface="Courier"/>
-              </a:rPr>
-              <a:t>%&gt;%</a:t>
-            </a:r>
-            <a:br/>
-            <a:r>
-              <a:rPr>
-                <a:solidFill>
-                  <a:srgbClr val="003B4F"/>
-                </a:solidFill>
-                <a:latin typeface="Courier"/>
-              </a:rPr>
-              <a:t>  </a:t>
-            </a:r>
-            <a:r>
-              <a:rPr>
-                <a:solidFill>
-                  <a:srgbClr val="4758AB"/>
-                </a:solidFill>
-                <a:latin typeface="Courier"/>
-              </a:rPr>
-              <a:t>select</a:t>
-            </a:r>
-            <a:r>
-              <a:rPr>
-                <a:solidFill>
-                  <a:srgbClr val="003B4F"/>
-                </a:solidFill>
-                <a:latin typeface="Courier"/>
-              </a:rPr>
-              <a:t>(shade, mass_g) </a:t>
-            </a:r>
-            <a:r>
-              <a:rPr>
-                <a:solidFill>
-                  <a:srgbClr val="5E5E5E"/>
-                </a:solidFill>
-                <a:latin typeface="Courier"/>
-              </a:rPr>
-              <a:t>%&gt;%</a:t>
-            </a:r>
-            <a:br/>
-            <a:r>
-              <a:rPr>
-                <a:solidFill>
-                  <a:srgbClr val="003B4F"/>
-                </a:solidFill>
-                <a:latin typeface="Courier"/>
-              </a:rPr>
-              <a:t>  </a:t>
-            </a:r>
-            <a:r>
-              <a:rPr>
-                <a:solidFill>
-                  <a:srgbClr val="4758AB"/>
-                </a:solidFill>
-                <a:latin typeface="Courier"/>
-              </a:rPr>
-              <a:t>group_by</a:t>
-            </a:r>
-            <a:r>
-              <a:rPr>
-                <a:solidFill>
-                  <a:srgbClr val="003B4F"/>
-                </a:solidFill>
-                <a:latin typeface="Courier"/>
-              </a:rPr>
-              <a:t>(shade) </a:t>
-            </a:r>
-            <a:r>
-              <a:rPr>
-                <a:solidFill>
-                  <a:srgbClr val="5E5E5E"/>
-                </a:solidFill>
-                <a:latin typeface="Courier"/>
-              </a:rPr>
-              <a:t>%&gt;%</a:t>
-            </a:r>
-            <a:br/>
-            <a:r>
-              <a:rPr>
-                <a:solidFill>
-                  <a:srgbClr val="003B4F"/>
-                </a:solidFill>
-                <a:latin typeface="Courier"/>
-              </a:rPr>
-              <a:t>  </a:t>
-            </a:r>
-            <a:r>
-              <a:rPr>
-                <a:solidFill>
-                  <a:srgbClr val="4758AB"/>
-                </a:solidFill>
-                <a:latin typeface="Courier"/>
-              </a:rPr>
-              <a:t>skim</a:t>
-            </a:r>
-            <a:r>
-              <a:rPr>
-                <a:solidFill>
-                  <a:srgbClr val="003B4F"/>
-                </a:solidFill>
-                <a:latin typeface="Courier"/>
-              </a:rPr>
-              <a:t>()</a:t>
-            </a:r>
-          </a:p>
-          <a:p>
-            <a:pPr lvl="0" indent="0" marL="0">
-              <a:buNone/>
-            </a:pPr>
-            <a:r>
-              <a:rPr b="1"/>
-              <a:t>Variable type: numeric</a:t>
-            </a:r>
-          </a:p>
-          <a:p>
             <a:pPr lvl="0" indent="0" marL="0">
               <a:buNone/>
             </a:pPr>
@@ -9644,7 +10616,7 @@
 </p:sld>
 </file>
 
-<file path=ppt/slides/slide27.xml><?xml version="1.0" encoding="utf-8"?>
+<file path=ppt/slides/slide29.xml><?xml version="1.0" encoding="utf-8"?>
 <p:sld xmlns:a="http://schemas.openxmlformats.org/drawingml/2006/main" xmlns:r="http://schemas.openxmlformats.org/officeDocument/2006/relationships" xmlns:p="http://schemas.openxmlformats.org/presentationml/2006/main">
   <p:cSld>
     <p:spTree>
@@ -10118,7 +11090,384 @@
 </p:sld>
 </file>
 
-<file path=ppt/slides/slide28.xml><?xml version="1.0" encoding="utf-8"?>
+<file path=ppt/slides/slide3.xml><?xml version="1.0" encoding="utf-8"?>
+<p:sld xmlns:a="http://schemas.openxmlformats.org/drawingml/2006/main" xmlns:r="http://schemas.openxmlformats.org/officeDocument/2006/relationships" xmlns:p="http://schemas.openxmlformats.org/presentationml/2006/main">
+  <p:cSld>
+    <p:spTree>
+      <p:nvGrpSpPr>
+        <p:cNvPr id="1" name=""/>
+        <p:cNvGrpSpPr/>
+        <p:nvPr/>
+      </p:nvGrpSpPr>
+      <p:grpSpPr>
+        <a:xfrm>
+          <a:off x="0" y="0"/>
+          <a:ext cx="0" cy="0"/>
+          <a:chOff x="0" y="0"/>
+          <a:chExt cx="0" cy="0"/>
+        </a:xfrm>
+      </p:grpSpPr>
+      <p:sp>
+        <p:nvSpPr>
+          <p:cNvPr id="2" name="Title 1"/>
+          <p:cNvSpPr>
+            <a:spLocks noGrp="1"/>
+          </p:cNvSpPr>
+          <p:nvPr>
+            <p:ph type="title"/>
+          </p:nvPr>
+        </p:nvSpPr>
+        <p:spPr>
+          <a:xfrm>
+            <a:off x="139485" y="78119"/>
+            <a:ext cx="8229600" cy="607682"/>
+          </a:xfrm>
+        </p:spPr>
+        <p:txBody>
+          <a:bodyPr/>
+          <a:lstStyle/>
+          <a:p>
+            <a:pPr lvl="0" indent="0" marL="0">
+              <a:buNone/>
+            </a:pPr>
+            <a:r>
+              <a:rPr/>
+              <a:t>Our Scientific Question</a:t>
+            </a:r>
+          </a:p>
+        </p:txBody>
+      </p:sp>
+      <p:sp>
+        <p:nvSpPr>
+          <p:cNvPr id="3" name="Text Placeholder 2"/>
+          <p:cNvSpPr>
+            <a:spLocks noGrp="1"/>
+          </p:cNvSpPr>
+          <p:nvPr>
+            <p:ph idx="1" type="body"/>
+          </p:nvPr>
+        </p:nvSpPr>
+        <p:spPr/>
+        <p:txBody>
+          <a:bodyPr/>
+          <a:lstStyle/>
+          <a:p>
+            <a:pPr lvl="0" indent="0" marL="0">
+              <a:buNone/>
+            </a:pPr>
+            <a:r>
+              <a:rPr b="1"/>
+              <a:t>Biological prediction:</a:t>
+            </a:r>
+            <a:r>
+              <a:rPr/>
+              <a:t> Leaves on the </a:t>
+            </a:r>
+            <a:r>
+              <a:rPr i="1"/>
+              <a:t>shady</a:t>
+            </a:r>
+            <a:r>
+              <a:rPr/>
+              <a:t> side of a tree will be </a:t>
+            </a:r>
+            <a:r>
+              <a:rPr b="1"/>
+              <a:t>larger and heavier</a:t>
+            </a:r>
+            <a:r>
+              <a:rPr/>
+              <a:t> to capture more of the limited light.</a:t>
+            </a:r>
+          </a:p>
+        </p:txBody>
+      </p:sp>
+      <p:graphicFrame>
+        <p:nvGraphicFramePr>
+          <p:cNvPr id="6" name="Content Placeholder 5"/>
+          <p:cNvGraphicFramePr>
+            <a:graphicFrameLocks noGrp="1"/>
+          </p:cNvGraphicFramePr>
+          <p:nvPr>
+            <p:ph idx="1"/>
+          </p:nvPr>
+        </p:nvGraphicFramePr>
+        <p:xfrm>
+          <a:off x="127000" y="1270000"/>
+          <a:ext cx="4432300" cy="3302000"/>
+        </p:xfrm>
+        <a:graphic>
+          <a:graphicData uri="http://schemas.openxmlformats.org/drawingml/2006/table">
+            <a:tbl>
+              <a:tblPr firstRow="1" bandRow="1">
+                <a:tableStyleId>{5C22544A-7EE6-4342-B048-85BDC9FD1C3A}</a:tableStyleId>
+              </a:tblPr>
+              <a:tblGrid>
+                <a:gridCol w="1143000"/>
+                <a:gridCol w="3289300"/>
+              </a:tblGrid>
+              <a:tr h="0">
+                <a:tc>
+                  <a:txBody>
+                    <a:bodyPr/>
+                    <a:lstStyle/>
+                    <a:p>
+                      <a:endParaRPr/>
+                    </a:p>
+                  </a:txBody>
+                  <a:tcPr/>
+                </a:tc>
+                <a:tc>
+                  <a:txBody>
+                    <a:bodyPr/>
+                    <a:lstStyle/>
+                    <a:p>
+                      <a:pPr lvl="0" indent="0" marL="0">
+                        <a:buNone/>
+                      </a:pPr>
+                      <a:r>
+                        <a:rPr/>
+                        <a:t>Hypothesis</a:t>
+                      </a:r>
+                    </a:p>
+                  </a:txBody>
+                  <a:tcPr/>
+                </a:tc>
+              </a:tr>
+              <a:tr h="0">
+                <a:tc>
+                  <a:txBody>
+                    <a:bodyPr/>
+                    <a:lstStyle/>
+                    <a:p>
+                      <a:pPr lvl="0" indent="0" marL="0">
+                        <a:buNone/>
+                      </a:pPr>
+                      <a:r>
+                        <a:rPr b="1"/>
+                        <a:t>H₀ — null</a:t>
+                      </a:r>
+                    </a:p>
+                  </a:txBody>
+                </a:tc>
+                <a:tc>
+                  <a:txBody>
+                    <a:bodyPr/>
+                    <a:lstStyle/>
+                    <a:p>
+                      <a:pPr lvl="0" indent="0" marL="0">
+                        <a:buNone/>
+                      </a:pPr>
+                      <a:r>
+                        <a:rPr/>
+                        <a:t>No difference in leaf size between sunny and shady sides</a:t>
+                      </a:r>
+                    </a:p>
+                  </a:txBody>
+                </a:tc>
+              </a:tr>
+              <a:tr h="0">
+                <a:tc>
+                  <a:txBody>
+                    <a:bodyPr/>
+                    <a:lstStyle/>
+                    <a:p>
+                      <a:pPr lvl="0" indent="0" marL="0">
+                        <a:buNone/>
+                      </a:pPr>
+                      <a:r>
+                        <a:rPr b="1"/>
+                        <a:t>Hₐ — alternate</a:t>
+                      </a:r>
+                    </a:p>
+                  </a:txBody>
+                </a:tc>
+                <a:tc>
+                  <a:txBody>
+                    <a:bodyPr/>
+                    <a:lstStyle/>
+                    <a:p>
+                      <a:pPr lvl="0" indent="0" marL="0">
+                        <a:buNone/>
+                      </a:pPr>
+                      <a:r>
+                        <a:rPr/>
+                        <a:t>Leaf size differs between sunny and shady sides</a:t>
+                      </a:r>
+                    </a:p>
+                  </a:txBody>
+                </a:tc>
+              </a:tr>
+            </a:tbl>
+          </a:graphicData>
+        </a:graphic>
+      </p:graphicFrame>
+      <p:sp>
+        <p:nvSpPr>
+          <p:cNvPr id="5" name="Text Placeholder 4"/>
+          <p:cNvSpPr>
+            <a:spLocks noGrp="1"/>
+          </p:cNvSpPr>
+          <p:nvPr>
+            <p:ph idx="3" sz="quarter" type="body"/>
+          </p:nvPr>
+        </p:nvSpPr>
+        <p:spPr/>
+        <p:txBody>
+          <a:bodyPr/>
+          <a:lstStyle/>
+          <a:p>
+            <a:pPr lvl="0" indent="0" marL="0">
+              <a:buNone/>
+            </a:pPr>
+            <a:r>
+              <a:rPr b="1"/>
+              <a:t>Plan for this unit:</a:t>
+            </a:r>
+          </a:p>
+          <a:p>
+            <a:pPr lvl="0" indent="-342900" marL="342900">
+              <a:buAutoNum type="arabicPeriod"/>
+            </a:pPr>
+            <a:r>
+              <a:rPr b="1"/>
+              <a:t>Today</a:t>
+            </a:r>
+            <a:r>
+              <a:rPr/>
+              <a:t> — </a:t>
+            </a:r>
+            <a:r>
+              <a:rPr i="1"/>
+              <a:t>describe</a:t>
+            </a:r>
+            <a:r>
+              <a:rPr/>
+              <a:t> the data</a:t>
+            </a:r>
+          </a:p>
+          <a:p>
+            <a:pPr lvl="0" indent="-342900" marL="342900">
+              <a:buAutoNum type="arabicPeriod"/>
+            </a:pPr>
+            <a:r>
+              <a:rPr b="1"/>
+              <a:t>Lecture 09</a:t>
+            </a:r>
+            <a:r>
+              <a:rPr/>
+              <a:t> — formally </a:t>
+            </a:r>
+            <a:r>
+              <a:rPr i="1"/>
+              <a:t>test</a:t>
+            </a:r>
+            <a:r>
+              <a:rPr/>
+              <a:t> the hypotheses with a t-test</a:t>
+            </a:r>
+          </a:p>
+          <a:p>
+            <a:pPr lvl="0" indent="0" marL="0">
+              <a:buNone/>
+            </a:pPr>
+            <a:r>
+              <a:rPr/>
+              <a:t>Statistics helps us decide which hypothesis is better supported by the data.</a:t>
+            </a:r>
+          </a:p>
+          <a:p>
+            <a:pPr lvl="0" indent="0" marL="0">
+              <a:buNone/>
+            </a:pPr>
+            <a:r>
+              <a:rPr b="1"/>
+              <a:t>References:</a:t>
+            </a:r>
+          </a:p>
+          <a:p>
+            <a:pPr lvl="0"/>
+            <a:r>
+              <a:rPr/>
+              <a:t>📖 Whitlock &amp; Schluter, Ch. 3 — </a:t>
+            </a:r>
+            <a:r>
+              <a:rPr i="1"/>
+              <a:t>Describing Data</a:t>
+            </a:r>
+          </a:p>
+          <a:p>
+            <a:pPr lvl="0"/>
+            <a:r>
+              <a:rPr/>
+              <a:t>📖 Whitlock &amp; Schluter, Ch. 4 — </a:t>
+            </a:r>
+            <a:r>
+              <a:rPr i="1"/>
+              <a:t>Estimating with Uncertainty</a:t>
+            </a:r>
+          </a:p>
+          <a:p>
+            <a:pPr lvl="0"/>
+            <a:r>
+              <a:rPr/>
+              <a:t>📖 </a:t>
+            </a:r>
+            <a:r>
+              <a:rPr>
+                <a:hlinkClick r:id="rId2"/>
+              </a:rPr>
+              <a:t>R4DS Ch 13</a:t>
+            </a:r>
+            <a:r>
+              <a:rPr/>
+              <a:t> — Numbers</a:t>
+            </a:r>
+          </a:p>
+          <a:p>
+            <a:pPr lvl="0"/>
+            <a:r>
+              <a:rPr/>
+              <a:t>📖 </a:t>
+            </a:r>
+            <a:r>
+              <a:rPr>
+                <a:hlinkClick r:id="rId3"/>
+              </a:rPr>
+              <a:t>R4DS Ch 18</a:t>
+            </a:r>
+            <a:r>
+              <a:rPr/>
+              <a:t> — Missing Values</a:t>
+            </a:r>
+          </a:p>
+          <a:p>
+            <a:pPr lvl="0" indent="0" marL="0">
+              <a:buNone/>
+            </a:pPr>
+            <a:r>
+              <a:rPr/>
+              <a:t>Both W&amp;S PDFs are in the course </a:t>
+            </a:r>
+            <a:r>
+              <a:rPr>
+                <a:latin typeface="Courier"/>
+              </a:rPr>
+              <a:t>readings/</a:t>
+            </a:r>
+            <a:r>
+              <a:rPr/>
+              <a:t> folder.</a:t>
+            </a:r>
+          </a:p>
+        </p:txBody>
+      </p:sp>
+    </p:spTree>
+  </p:cSld>
+</p:sld>
+</file>
+
+<file path=ppt/slides/slide30.xml><?xml version="1.0" encoding="utf-8"?>
 <p:sld xmlns:a="http://schemas.openxmlformats.org/drawingml/2006/main" xmlns:r="http://schemas.openxmlformats.org/officeDocument/2006/relationships" xmlns:p="http://schemas.openxmlformats.org/presentationml/2006/main">
   <p:cSld>
     <p:spTree>
@@ -10204,7 +11553,7 @@
 </p:sld>
 </file>
 
-<file path=ppt/slides/slide29.xml><?xml version="1.0" encoding="utf-8"?>
+<file path=ppt/slides/slide31.xml><?xml version="1.0" encoding="utf-8"?>
 <p:sld xmlns:a="http://schemas.openxmlformats.org/drawingml/2006/main" xmlns:r="http://schemas.openxmlformats.org/officeDocument/2006/relationships" xmlns:p="http://schemas.openxmlformats.org/presentationml/2006/main">
   <p:cSld>
     <p:spTree>
@@ -10616,383 +11965,6 @@
             <a:r>
               <a:rPr/>
               <a:t>Mixing prose, code, and results in one document</a:t>
-            </a:r>
-          </a:p>
-        </p:txBody>
-      </p:sp>
-    </p:spTree>
-  </p:cSld>
-</p:sld>
-</file>
-
-<file path=ppt/slides/slide3.xml><?xml version="1.0" encoding="utf-8"?>
-<p:sld xmlns:a="http://schemas.openxmlformats.org/drawingml/2006/main" xmlns:r="http://schemas.openxmlformats.org/officeDocument/2006/relationships" xmlns:p="http://schemas.openxmlformats.org/presentationml/2006/main">
-  <p:cSld>
-    <p:spTree>
-      <p:nvGrpSpPr>
-        <p:cNvPr id="1" name=""/>
-        <p:cNvGrpSpPr/>
-        <p:nvPr/>
-      </p:nvGrpSpPr>
-      <p:grpSpPr>
-        <a:xfrm>
-          <a:off x="0" y="0"/>
-          <a:ext cx="0" cy="0"/>
-          <a:chOff x="0" y="0"/>
-          <a:chExt cx="0" cy="0"/>
-        </a:xfrm>
-      </p:grpSpPr>
-      <p:sp>
-        <p:nvSpPr>
-          <p:cNvPr id="2" name="Title 1"/>
-          <p:cNvSpPr>
-            <a:spLocks noGrp="1"/>
-          </p:cNvSpPr>
-          <p:nvPr>
-            <p:ph type="title"/>
-          </p:nvPr>
-        </p:nvSpPr>
-        <p:spPr>
-          <a:xfrm>
-            <a:off x="139485" y="78119"/>
-            <a:ext cx="8229600" cy="607682"/>
-          </a:xfrm>
-        </p:spPr>
-        <p:txBody>
-          <a:bodyPr/>
-          <a:lstStyle/>
-          <a:p>
-            <a:pPr lvl="0" indent="0" marL="0">
-              <a:buNone/>
-            </a:pPr>
-            <a:r>
-              <a:rPr/>
-              <a:t>Our Scientific Question</a:t>
-            </a:r>
-          </a:p>
-        </p:txBody>
-      </p:sp>
-      <p:sp>
-        <p:nvSpPr>
-          <p:cNvPr id="3" name="Text Placeholder 2"/>
-          <p:cNvSpPr>
-            <a:spLocks noGrp="1"/>
-          </p:cNvSpPr>
-          <p:nvPr>
-            <p:ph idx="1" type="body"/>
-          </p:nvPr>
-        </p:nvSpPr>
-        <p:spPr/>
-        <p:txBody>
-          <a:bodyPr/>
-          <a:lstStyle/>
-          <a:p>
-            <a:pPr lvl="0" indent="0" marL="0">
-              <a:buNone/>
-            </a:pPr>
-            <a:r>
-              <a:rPr b="1"/>
-              <a:t>Biological prediction:</a:t>
-            </a:r>
-            <a:r>
-              <a:rPr/>
-              <a:t> Leaves on the </a:t>
-            </a:r>
-            <a:r>
-              <a:rPr i="1"/>
-              <a:t>shady</a:t>
-            </a:r>
-            <a:r>
-              <a:rPr/>
-              <a:t> side of a tree will be </a:t>
-            </a:r>
-            <a:r>
-              <a:rPr b="1"/>
-              <a:t>larger and heavier</a:t>
-            </a:r>
-            <a:r>
-              <a:rPr/>
-              <a:t> to capture more of the limited light.</a:t>
-            </a:r>
-          </a:p>
-        </p:txBody>
-      </p:sp>
-      <p:graphicFrame>
-        <p:nvGraphicFramePr>
-          <p:cNvPr id="6" name="Content Placeholder 5"/>
-          <p:cNvGraphicFramePr>
-            <a:graphicFrameLocks noGrp="1"/>
-          </p:cNvGraphicFramePr>
-          <p:nvPr>
-            <p:ph idx="1"/>
-          </p:nvPr>
-        </p:nvGraphicFramePr>
-        <p:xfrm>
-          <a:off x="127000" y="1270000"/>
-          <a:ext cx="4432300" cy="3302000"/>
-        </p:xfrm>
-        <a:graphic>
-          <a:graphicData uri="http://schemas.openxmlformats.org/drawingml/2006/table">
-            <a:tbl>
-              <a:tblPr firstRow="1" bandRow="1">
-                <a:tableStyleId>{5C22544A-7EE6-4342-B048-85BDC9FD1C3A}</a:tableStyleId>
-              </a:tblPr>
-              <a:tblGrid>
-                <a:gridCol w="1143000"/>
-                <a:gridCol w="3289300"/>
-              </a:tblGrid>
-              <a:tr h="0">
-                <a:tc>
-                  <a:txBody>
-                    <a:bodyPr/>
-                    <a:lstStyle/>
-                    <a:p>
-                      <a:endParaRPr/>
-                    </a:p>
-                  </a:txBody>
-                  <a:tcPr/>
-                </a:tc>
-                <a:tc>
-                  <a:txBody>
-                    <a:bodyPr/>
-                    <a:lstStyle/>
-                    <a:p>
-                      <a:pPr lvl="0" indent="0" marL="0">
-                        <a:buNone/>
-                      </a:pPr>
-                      <a:r>
-                        <a:rPr/>
-                        <a:t>Hypothesis</a:t>
-                      </a:r>
-                    </a:p>
-                  </a:txBody>
-                  <a:tcPr/>
-                </a:tc>
-              </a:tr>
-              <a:tr h="0">
-                <a:tc>
-                  <a:txBody>
-                    <a:bodyPr/>
-                    <a:lstStyle/>
-                    <a:p>
-                      <a:pPr lvl="0" indent="0" marL="0">
-                        <a:buNone/>
-                      </a:pPr>
-                      <a:r>
-                        <a:rPr b="1"/>
-                        <a:t>H₀ — null</a:t>
-                      </a:r>
-                    </a:p>
-                  </a:txBody>
-                </a:tc>
-                <a:tc>
-                  <a:txBody>
-                    <a:bodyPr/>
-                    <a:lstStyle/>
-                    <a:p>
-                      <a:pPr lvl="0" indent="0" marL="0">
-                        <a:buNone/>
-                      </a:pPr>
-                      <a:r>
-                        <a:rPr/>
-                        <a:t>No difference in leaf size between sunny and shady sides</a:t>
-                      </a:r>
-                    </a:p>
-                  </a:txBody>
-                </a:tc>
-              </a:tr>
-              <a:tr h="0">
-                <a:tc>
-                  <a:txBody>
-                    <a:bodyPr/>
-                    <a:lstStyle/>
-                    <a:p>
-                      <a:pPr lvl="0" indent="0" marL="0">
-                        <a:buNone/>
-                      </a:pPr>
-                      <a:r>
-                        <a:rPr b="1"/>
-                        <a:t>Hₐ — alternate</a:t>
-                      </a:r>
-                    </a:p>
-                  </a:txBody>
-                </a:tc>
-                <a:tc>
-                  <a:txBody>
-                    <a:bodyPr/>
-                    <a:lstStyle/>
-                    <a:p>
-                      <a:pPr lvl="0" indent="0" marL="0">
-                        <a:buNone/>
-                      </a:pPr>
-                      <a:r>
-                        <a:rPr/>
-                        <a:t>Leaf size differs between sunny and shady sides</a:t>
-                      </a:r>
-                    </a:p>
-                  </a:txBody>
-                </a:tc>
-              </a:tr>
-            </a:tbl>
-          </a:graphicData>
-        </a:graphic>
-      </p:graphicFrame>
-      <p:sp>
-        <p:nvSpPr>
-          <p:cNvPr id="5" name="Text Placeholder 4"/>
-          <p:cNvSpPr>
-            <a:spLocks noGrp="1"/>
-          </p:cNvSpPr>
-          <p:nvPr>
-            <p:ph idx="3" sz="quarter" type="body"/>
-          </p:nvPr>
-        </p:nvSpPr>
-        <p:spPr/>
-        <p:txBody>
-          <a:bodyPr/>
-          <a:lstStyle/>
-          <a:p>
-            <a:pPr lvl="0" indent="0" marL="0">
-              <a:buNone/>
-            </a:pPr>
-            <a:r>
-              <a:rPr b="1"/>
-              <a:t>Plan for this unit:</a:t>
-            </a:r>
-          </a:p>
-          <a:p>
-            <a:pPr lvl="0" indent="-342900" marL="342900">
-              <a:buAutoNum type="arabicPeriod"/>
-            </a:pPr>
-            <a:r>
-              <a:rPr b="1"/>
-              <a:t>Today</a:t>
-            </a:r>
-            <a:r>
-              <a:rPr/>
-              <a:t> — </a:t>
-            </a:r>
-            <a:r>
-              <a:rPr i="1"/>
-              <a:t>describe</a:t>
-            </a:r>
-            <a:r>
-              <a:rPr/>
-              <a:t> the data</a:t>
-            </a:r>
-          </a:p>
-          <a:p>
-            <a:pPr lvl="0" indent="-342900" marL="342900">
-              <a:buAutoNum type="arabicPeriod"/>
-            </a:pPr>
-            <a:r>
-              <a:rPr b="1"/>
-              <a:t>Lecture 09</a:t>
-            </a:r>
-            <a:r>
-              <a:rPr/>
-              <a:t> — formally </a:t>
-            </a:r>
-            <a:r>
-              <a:rPr i="1"/>
-              <a:t>test</a:t>
-            </a:r>
-            <a:r>
-              <a:rPr/>
-              <a:t> the hypotheses with a t-test</a:t>
-            </a:r>
-          </a:p>
-          <a:p>
-            <a:pPr lvl="0" indent="0" marL="0">
-              <a:buNone/>
-            </a:pPr>
-            <a:r>
-              <a:rPr/>
-              <a:t>Statistics helps us decide which hypothesis is better supported by the data.</a:t>
-            </a:r>
-          </a:p>
-          <a:p>
-            <a:pPr lvl="0" indent="0" marL="0">
-              <a:buNone/>
-            </a:pPr>
-            <a:r>
-              <a:rPr b="1"/>
-              <a:t>References:</a:t>
-            </a:r>
-          </a:p>
-          <a:p>
-            <a:pPr lvl="0"/>
-            <a:r>
-              <a:rPr/>
-              <a:t>📖 Whitlock &amp; Schluter, Ch. 3 — </a:t>
-            </a:r>
-            <a:r>
-              <a:rPr i="1"/>
-              <a:t>Describing Data</a:t>
-            </a:r>
-          </a:p>
-          <a:p>
-            <a:pPr lvl="0"/>
-            <a:r>
-              <a:rPr/>
-              <a:t>📖 Whitlock &amp; Schluter, Ch. 4 — </a:t>
-            </a:r>
-            <a:r>
-              <a:rPr i="1"/>
-              <a:t>Estimating with Uncertainty</a:t>
-            </a:r>
-          </a:p>
-          <a:p>
-            <a:pPr lvl="0"/>
-            <a:r>
-              <a:rPr/>
-              <a:t>📖 </a:t>
-            </a:r>
-            <a:r>
-              <a:rPr>
-                <a:hlinkClick r:id="rId2"/>
-              </a:rPr>
-              <a:t>R4DS Ch 13</a:t>
-            </a:r>
-            <a:r>
-              <a:rPr/>
-              <a:t> — Numbers</a:t>
-            </a:r>
-          </a:p>
-          <a:p>
-            <a:pPr lvl="0"/>
-            <a:r>
-              <a:rPr/>
-              <a:t>📖 </a:t>
-            </a:r>
-            <a:r>
-              <a:rPr>
-                <a:hlinkClick r:id="rId3"/>
-              </a:rPr>
-              <a:t>R4DS Ch 18</a:t>
-            </a:r>
-            <a:r>
-              <a:rPr/>
-              <a:t> — Missing Values</a:t>
-            </a:r>
-          </a:p>
-          <a:p>
-            <a:pPr lvl="0" indent="0" marL="0">
-              <a:buNone/>
-            </a:pPr>
-            <a:r>
-              <a:rPr/>
-              <a:t>Both W&amp;S PDFs are in the course </a:t>
-            </a:r>
-            <a:r>
-              <a:rPr>
-                <a:latin typeface="Courier"/>
-              </a:rPr>
-              <a:t>readings/</a:t>
-            </a:r>
-            <a:r>
-              <a:rPr/>
-              <a:t> folder.</a:t>
             </a:r>
           </a:p>
         </p:txBody>

</xml_diff>